<commit_message>
PTT relay is operator-switched: fix slide 6 and README wording
Co-Authored-By: Claude Opus 5.5 <noreply@anthropic.com>
</commit_message>
<xml_diff>
--- a/presentation/Jetson_DATV_presentation_v2.pptx
+++ b/presentation/Jetson_DATV_presentation_v2.pptx
@@ -752,7 +752,7 @@
             </a:pPr>
             <a:r>
               <a:rPr/>
-              <a:t>While transmitting, card 1 becomes the On-air monitor: your own signal received back through QO-100 by OpenTuner, with margin, MER and lock. The local Pluto RX spectrum shows the Pluto really transmits. The optional PTT relay (physical pin 18) enables the power amplifier only once the signal is stable, because the Pluto can spike at start. The Pluto's own frequency error is measured on your signal and applied from the next start.</a:t>
+              <a:t>While transmitting, card 1 becomes the On-air monitor: your own signal received back through QO-100 by OpenTuner, with margin, MER and lock. The local Pluto RX spectrum shows the Pluto really transmits. The optional PTT relay (physical pin 18) switches the power amplifier: you switch it on once the local spectrum looks stable, because the Pluto can spike at start. It switches off automatically when the stream stops. The Pluto's own frequency error is measured on your signal and applied from the next start.</a:t>
             </a:r>
             <a:endParaRPr/>
           </a:p>
@@ -9139,7 +9139,7 @@
                 </a:solidFill>
                 <a:latin typeface="Arial"/>
               </a:rPr>
-              <a:t>PA switched on only once the signal is stable</a:t>
+              <a:t>You switch it on once the signal looks stable</a:t>
             </a:r>
             <a:endParaRPr/>
           </a:p>

</xml_diff>